<commit_message>
Remove XGBoost: focus on LSTM vs Transformer comparison
</commit_message>
<xml_diff>
--- a/期末報告_台股AI量化分析平台.pptx
+++ b/期末報告_台股AI量化分析平台.pptx
@@ -141,7 +141,7 @@
                 </a:solidFill>
                 <a:latin typeface="Calibri"/>
               </a:rPr>
-              <a:t>三模型 RMSE 比較</a:t>
+              <a:t>兩模型 RMSE 比較 (元)</a:t>
             </a:r>
           </a:p>
         </c:rich>
@@ -223,22 +223,11 @@
               <a:effectLst/>
             </c:spPr>
           </c:dPt>
-          <c:dPt>
-            <c:idx val="2"/>
-            <c:invertIfNegative val="0"/>
-            <c:bubble3D val="0"/>
-            <c:spPr>
-              <a:solidFill>
-                <a:srgbClr val="0D9488"/>
-              </a:solidFill>
-              <a:effectLst/>
-            </c:spPr>
-          </c:dPt>
           <c:cat>
             <c:multiLvlStrRef>
-              <c:f>Sheet1!$A$2:$A$4</c:f>
+              <c:f>Sheet1!$A$2:$A$3</c:f>
               <c:multiLvlStrCache>
-                <c:ptCount val="3"/>
+                <c:ptCount val="2"/>
                 <c:lvl>
                   <c:pt idx="0">
                     <c:v>LSTM</c:v>
@@ -246,27 +235,21 @@
                   <c:pt idx="1">
                     <c:v>Transformer</c:v>
                   </c:pt>
-                  <c:pt idx="2">
-                    <c:v>XGBoost</c:v>
-                  </c:pt>
                 </c:lvl>
               </c:multiLvlStrCache>
             </c:multiLvlStrRef>
           </c:cat>
           <c:val>
             <c:numRef>
-              <c:f>Sheet1!$B$2:$B$4</c:f>
+              <c:f>Sheet1!$B$2:$B$3</c:f>
               <c:numCache>
                 <c:formatCode>General</c:formatCode>
-                <c:ptCount val="3"/>
+                <c:ptCount val="2"/>
                 <c:pt idx="0">
-                  <c:v>12.34</c:v>
+                  <c:v>97.41</c:v>
                 </c:pt>
                 <c:pt idx="1">
-                  <c:v>10.87</c:v>
-                </c:pt>
-                <c:pt idx="2">
-                  <c:v>14.52</c:v>
+                  <c:v>112.68</c:v>
                 </c:pt>
               </c:numCache>
             </c:numRef>
@@ -2970,7 +2953,7 @@
                 <a:ea typeface="Calibri" pitchFamily="34" charset="-122"/>
                 <a:cs typeface="Calibri" pitchFamily="34" charset="-120"/>
               </a:rPr>
-              <a:t>整合 LSTM / Transformer / XGBoost 三模型同台比較。</a:t>
+              <a:t>深度學習 LSTM 與 Transformer 兩大主流時序模型對比。</a:t>
             </a:r>
             <a:endParaRPr lang="en-US" sz="1400" dirty="0"/>
           </a:p>
@@ -3612,7 +3595,7 @@
                 <a:ea typeface="Calibri" pitchFamily="34" charset="-122"/>
                 <a:cs typeface="Calibri" pitchFamily="34" charset="-120"/>
               </a:rPr>
-              <a:t>LSTM · Transformer · XGBoost</a:t>
+              <a:t>LSTM · Transformer (PyTorch)</a:t>
             </a:r>
             <a:endParaRPr lang="en-US" sz="1100" dirty="0"/>
           </a:p>
@@ -4583,7 +4566,7 @@
                 <a:ea typeface="Calibri" pitchFamily="34" charset="-122"/>
                 <a:cs typeface="Calibri" pitchFamily="34" charset="-120"/>
               </a:rPr>
-              <a:t>AI 模型: 三方對戰</a:t>
+              <a:t>AI 模型: 雙雄對決</a:t>
             </a:r>
             <a:endParaRPr lang="en-US" sz="3200" dirty="0"/>
           </a:p>
@@ -4622,7 +4605,7 @@
                 <a:ea typeface="Calibri" pitchFamily="34" charset="-122"/>
                 <a:cs typeface="Calibri" pitchFamily="34" charset="-120"/>
               </a:rPr>
-              <a:t>深度學習 (LSTM, Transformer) vs. 機器學習基準 (XGBoost)</a:t>
+              <a:t>LSTM (經典 RNN) vs. Transformer (現代 Self-Attention) — 兩大主流時序模型對決</a:t>
             </a:r>
             <a:endParaRPr lang="en-US" sz="1400" dirty="0"/>
           </a:p>
@@ -4636,8 +4619,8 @@
         </p:nvSpPr>
         <p:spPr>
           <a:xfrm>
-            <a:off x="457200" y="1280160"/>
-            <a:ext cx="2697480" cy="3657600"/>
+            <a:off x="640080" y="1280160"/>
+            <a:ext cx="3794760" cy="3657600"/>
           </a:xfrm>
           <a:prstGeom prst="rect">
             <a:avLst/>
@@ -4661,8 +4644,8 @@
         </p:nvSpPr>
         <p:spPr>
           <a:xfrm>
-            <a:off x="457200" y="1280160"/>
-            <a:ext cx="2697480" cy="640080"/>
+            <a:off x="640080" y="1280160"/>
+            <a:ext cx="3794760" cy="731520"/>
           </a:xfrm>
           <a:prstGeom prst="rect">
             <a:avLst/>
@@ -4681,8 +4664,8 @@
         </p:nvSpPr>
         <p:spPr>
           <a:xfrm>
-            <a:off x="594360" y="1298448"/>
-            <a:ext cx="2468880" cy="411480"/>
+            <a:off x="822960" y="1325880"/>
+            <a:ext cx="3520440" cy="457200"/>
           </a:xfrm>
           <a:prstGeom prst="rect">
             <a:avLst/>
@@ -4698,7 +4681,7 @@
               <a:buNone/>
             </a:pPr>
             <a:r>
-              <a:rPr lang="en-US" sz="2200" b="1" dirty="0">
+              <a:rPr lang="en-US" sz="2600" b="1" dirty="0">
                 <a:solidFill>
                   <a:srgbClr val="FFFFFF"/>
                 </a:solidFill>
@@ -4708,7 +4691,7 @@
               </a:rPr>
               <a:t>LSTM</a:t>
             </a:r>
-            <a:endParaRPr lang="en-US" sz="2200" dirty="0"/>
+            <a:endParaRPr lang="en-US" sz="2600" dirty="0"/>
           </a:p>
         </p:txBody>
       </p:sp>
@@ -4720,8 +4703,8 @@
         </p:nvSpPr>
         <p:spPr>
           <a:xfrm>
-            <a:off x="594360" y="1664208"/>
-            <a:ext cx="2468880" cy="228600"/>
+            <a:off x="822960" y="1755648"/>
+            <a:ext cx="3520440" cy="274320"/>
           </a:xfrm>
           <a:prstGeom prst="rect">
             <a:avLst/>
@@ -4737,7 +4720,7 @@
               <a:buNone/>
             </a:pPr>
             <a:r>
-              <a:rPr lang="en-US" sz="1000" i="1" dirty="0">
+              <a:rPr lang="en-US" sz="1100" i="1" dirty="0">
                 <a:solidFill>
                   <a:srgbClr val="FFFFFF"/>
                 </a:solidFill>
@@ -4747,7 +4730,7 @@
               </a:rPr>
               <a:t>Long Short-Term Memory</a:t>
             </a:r>
-            <a:endParaRPr lang="en-US" sz="1000" dirty="0"/>
+            <a:endParaRPr lang="en-US" sz="1100" dirty="0"/>
           </a:p>
         </p:txBody>
       </p:sp>
@@ -4759,8 +4742,8 @@
         </p:nvSpPr>
         <p:spPr>
           <a:xfrm>
-            <a:off x="594360" y="2057400"/>
-            <a:ext cx="2468880" cy="228600"/>
+            <a:off x="822960" y="2194560"/>
+            <a:ext cx="3520440" cy="274320"/>
           </a:xfrm>
           <a:prstGeom prst="rect">
             <a:avLst/>
@@ -4776,7 +4759,7 @@
               <a:buNone/>
             </a:pPr>
             <a:r>
-              <a:rPr lang="en-US" sz="1100" b="1" dirty="0">
+              <a:rPr lang="en-US" sz="1300" b="1" dirty="0">
                 <a:solidFill>
                   <a:srgbClr val="1E2761"/>
                 </a:solidFill>
@@ -4786,7 +4769,7 @@
               </a:rPr>
               <a:t>架構</a:t>
             </a:r>
-            <a:endParaRPr lang="en-US" sz="1100" dirty="0"/>
+            <a:endParaRPr lang="en-US" sz="1300" dirty="0"/>
           </a:p>
         </p:txBody>
       </p:sp>
@@ -4798,8 +4781,8 @@
         </p:nvSpPr>
         <p:spPr>
           <a:xfrm>
-            <a:off x="594360" y="2286000"/>
-            <a:ext cx="2468880" cy="914400"/>
+            <a:off x="822960" y="2468880"/>
+            <a:ext cx="3520440" cy="1005840"/>
           </a:xfrm>
           <a:prstGeom prst="rect">
             <a:avLst/>
@@ -4815,7 +4798,7 @@
               <a:buNone/>
             </a:pPr>
             <a:r>
-              <a:rPr lang="en-US" sz="1100" dirty="0">
+              <a:rPr lang="en-US" sz="1200" dirty="0">
                 <a:solidFill>
                   <a:srgbClr val="1A1A2E"/>
                 </a:solidFill>
@@ -4823,9 +4806,43 @@
                 <a:ea typeface="Calibri" pitchFamily="34" charset="-122"/>
                 <a:cs typeface="Calibri" pitchFamily="34" charset="-120"/>
               </a:rPr>
-              <a:t>雙層 LSTM(64) + Dropout(0.2) + FC</a:t>
-            </a:r>
-            <a:endParaRPr lang="en-US" sz="1100" dirty="0"/>
+              <a:t>雙層 LSTM(64) + Dropout(0.2)</a:t>
+            </a:r>
+            <a:endParaRPr lang="en-US" sz="1200" dirty="0"/>
+          </a:p>
+          <a:p>
+            <a:pPr indent="0" marL="0">
+              <a:buNone/>
+            </a:pPr>
+            <a:r>
+              <a:rPr lang="en-US" sz="1200" dirty="0">
+                <a:solidFill>
+                  <a:srgbClr val="1A1A2E"/>
+                </a:solidFill>
+                <a:latin typeface="Calibri" pitchFamily="34" charset="0"/>
+                <a:ea typeface="Calibri" pitchFamily="34" charset="-122"/>
+                <a:cs typeface="Calibri" pitchFamily="34" charset="-120"/>
+              </a:rPr>
+              <a:t>+ Fully Connected 輸出層</a:t>
+            </a:r>
+            <a:endParaRPr lang="en-US" sz="1200" dirty="0"/>
+          </a:p>
+          <a:p>
+            <a:pPr indent="0" marL="0">
+              <a:buNone/>
+            </a:pPr>
+            <a:r>
+              <a:rPr lang="en-US" sz="1200" dirty="0">
+                <a:solidFill>
+                  <a:srgbClr val="1A1A2E"/>
+                </a:solidFill>
+                <a:latin typeface="Calibri" pitchFamily="34" charset="0"/>
+                <a:ea typeface="Calibri" pitchFamily="34" charset="-122"/>
+                <a:cs typeface="Calibri" pitchFamily="34" charset="-120"/>
+              </a:rPr>
+              <a:t>Lookback = 30 天</a:t>
+            </a:r>
+            <a:endParaRPr lang="en-US" sz="1200" dirty="0"/>
           </a:p>
         </p:txBody>
       </p:sp>
@@ -4837,8 +4854,8 @@
         </p:nvSpPr>
         <p:spPr>
           <a:xfrm>
-            <a:off x="594360" y="3383280"/>
-            <a:ext cx="2468880" cy="228600"/>
+            <a:off x="822960" y="3611880"/>
+            <a:ext cx="3520440" cy="274320"/>
           </a:xfrm>
           <a:prstGeom prst="rect">
             <a:avLst/>
@@ -4854,7 +4871,7 @@
               <a:buNone/>
             </a:pPr>
             <a:r>
-              <a:rPr lang="en-US" sz="1100" b="1" dirty="0">
+              <a:rPr lang="en-US" sz="1300" b="1" dirty="0">
                 <a:solidFill>
                   <a:srgbClr val="1E2761"/>
                 </a:solidFill>
@@ -4864,7 +4881,7 @@
               </a:rPr>
               <a:t>優勢</a:t>
             </a:r>
-            <a:endParaRPr lang="en-US" sz="1100" dirty="0"/>
+            <a:endParaRPr lang="en-US" sz="1300" dirty="0"/>
           </a:p>
         </p:txBody>
       </p:sp>
@@ -4876,8 +4893,8 @@
         </p:nvSpPr>
         <p:spPr>
           <a:xfrm>
-            <a:off x="594360" y="3611880"/>
-            <a:ext cx="2468880" cy="1188720"/>
+            <a:off x="822960" y="3886200"/>
+            <a:ext cx="3520440" cy="1005840"/>
           </a:xfrm>
           <a:prstGeom prst="rect">
             <a:avLst/>
@@ -4896,7 +4913,7 @@
               <a:buNone/>
             </a:pPr>
             <a:r>
-              <a:rPr lang="en-US" sz="1100" dirty="0">
+              <a:rPr lang="en-US" sz="1200" dirty="0">
                 <a:solidFill>
                   <a:srgbClr val="1A1A2E"/>
                 </a:solidFill>
@@ -4904,9 +4921,9 @@
                 <a:ea typeface="Calibri" pitchFamily="34" charset="-122"/>
                 <a:cs typeface="Calibri" pitchFamily="34" charset="-120"/>
               </a:rPr>
-              <a:t>經典時序模型</a:t>
-            </a:r>
-            <a:endParaRPr lang="en-US" sz="1100" dirty="0"/>
+              <a:t>經典時序模型，訓練穩定</a:t>
+            </a:r>
+            <a:endParaRPr lang="en-US" sz="1200" dirty="0"/>
           </a:p>
           <a:p>
             <a:pPr indent="0" marL="0">
@@ -4916,7 +4933,7 @@
               <a:buNone/>
             </a:pPr>
             <a:r>
-              <a:rPr lang="en-US" sz="1100" dirty="0">
+              <a:rPr lang="en-US" sz="1200" dirty="0">
                 <a:solidFill>
                   <a:srgbClr val="1A1A2E"/>
                 </a:solidFill>
@@ -4924,9 +4941,9 @@
                 <a:ea typeface="Calibri" pitchFamily="34" charset="-122"/>
                 <a:cs typeface="Calibri" pitchFamily="34" charset="-120"/>
               </a:rPr>
-              <a:t>趨勢捕捉強</a:t>
-            </a:r>
-            <a:endParaRPr lang="en-US" sz="1100" dirty="0"/>
+              <a:t>小資料情境表現出色</a:t>
+            </a:r>
+            <a:endParaRPr lang="en-US" sz="1200" dirty="0"/>
           </a:p>
           <a:p>
             <a:pPr indent="0" marL="0">
@@ -4936,7 +4953,7 @@
               <a:buNone/>
             </a:pPr>
             <a:r>
-              <a:rPr lang="en-US" sz="1100" dirty="0">
+              <a:rPr lang="en-US" sz="1200" dirty="0">
                 <a:solidFill>
                   <a:srgbClr val="1A1A2E"/>
                 </a:solidFill>
@@ -4944,9 +4961,9 @@
                 <a:ea typeface="Calibri" pitchFamily="34" charset="-122"/>
                 <a:cs typeface="Calibri" pitchFamily="34" charset="-120"/>
               </a:rPr>
-              <a:t>訓練穩定</a:t>
-            </a:r>
-            <a:endParaRPr lang="en-US" sz="1100" dirty="0"/>
+              <a:t>趨勢捕捉能力強</a:t>
+            </a:r>
+            <a:endParaRPr lang="en-US" sz="1200" dirty="0"/>
           </a:p>
         </p:txBody>
       </p:sp>
@@ -4958,8 +4975,8 @@
         </p:nvSpPr>
         <p:spPr>
           <a:xfrm>
-            <a:off x="3520440" y="1280160"/>
-            <a:ext cx="2697480" cy="3657600"/>
+            <a:off x="4709160" y="1280160"/>
+            <a:ext cx="3794760" cy="3657600"/>
           </a:xfrm>
           <a:prstGeom prst="rect">
             <a:avLst/>
@@ -4983,8 +5000,8 @@
         </p:nvSpPr>
         <p:spPr>
           <a:xfrm>
-            <a:off x="3520440" y="1280160"/>
-            <a:ext cx="2697480" cy="640080"/>
+            <a:off x="4709160" y="1280160"/>
+            <a:ext cx="3794760" cy="731520"/>
           </a:xfrm>
           <a:prstGeom prst="rect">
             <a:avLst/>
@@ -5003,8 +5020,8 @@
         </p:nvSpPr>
         <p:spPr>
           <a:xfrm>
-            <a:off x="3657600" y="1298448"/>
-            <a:ext cx="2468880" cy="411480"/>
+            <a:off x="4892040" y="1325880"/>
+            <a:ext cx="3520440" cy="457200"/>
           </a:xfrm>
           <a:prstGeom prst="rect">
             <a:avLst/>
@@ -5020,7 +5037,7 @@
               <a:buNone/>
             </a:pPr>
             <a:r>
-              <a:rPr lang="en-US" sz="2200" b="1" dirty="0">
+              <a:rPr lang="en-US" sz="2600" b="1" dirty="0">
                 <a:solidFill>
                   <a:srgbClr val="FFFFFF"/>
                 </a:solidFill>
@@ -5030,7 +5047,7 @@
               </a:rPr>
               <a:t>Transformer</a:t>
             </a:r>
-            <a:endParaRPr lang="en-US" sz="2200" dirty="0"/>
+            <a:endParaRPr lang="en-US" sz="2600" dirty="0"/>
           </a:p>
         </p:txBody>
       </p:sp>
@@ -5042,8 +5059,8 @@
         </p:nvSpPr>
         <p:spPr>
           <a:xfrm>
-            <a:off x="3657600" y="1664208"/>
-            <a:ext cx="2468880" cy="228600"/>
+            <a:off x="4892040" y="1755648"/>
+            <a:ext cx="3520440" cy="274320"/>
           </a:xfrm>
           <a:prstGeom prst="rect">
             <a:avLst/>
@@ -5059,7 +5076,7 @@
               <a:buNone/>
             </a:pPr>
             <a:r>
-              <a:rPr lang="en-US" sz="1000" i="1" dirty="0">
+              <a:rPr lang="en-US" sz="1100" i="1" dirty="0">
                 <a:solidFill>
                   <a:srgbClr val="FFFFFF"/>
                 </a:solidFill>
@@ -5069,7 +5086,7 @@
               </a:rPr>
               <a:t>Self-Attention Encoder</a:t>
             </a:r>
-            <a:endParaRPr lang="en-US" sz="1000" dirty="0"/>
+            <a:endParaRPr lang="en-US" sz="1100" dirty="0"/>
           </a:p>
         </p:txBody>
       </p:sp>
@@ -5081,8 +5098,8 @@
         </p:nvSpPr>
         <p:spPr>
           <a:xfrm>
-            <a:off x="3657600" y="2057400"/>
-            <a:ext cx="2468880" cy="228600"/>
+            <a:off x="4892040" y="2194560"/>
+            <a:ext cx="3520440" cy="274320"/>
           </a:xfrm>
           <a:prstGeom prst="rect">
             <a:avLst/>
@@ -5098,7 +5115,7 @@
               <a:buNone/>
             </a:pPr>
             <a:r>
-              <a:rPr lang="en-US" sz="1100" b="1" dirty="0">
+              <a:rPr lang="en-US" sz="1300" b="1" dirty="0">
                 <a:solidFill>
                   <a:srgbClr val="F96167"/>
                 </a:solidFill>
@@ -5108,7 +5125,7 @@
               </a:rPr>
               <a:t>架構</a:t>
             </a:r>
-            <a:endParaRPr lang="en-US" sz="1100" dirty="0"/>
+            <a:endParaRPr lang="en-US" sz="1300" dirty="0"/>
           </a:p>
         </p:txBody>
       </p:sp>
@@ -5120,8 +5137,8 @@
         </p:nvSpPr>
         <p:spPr>
           <a:xfrm>
-            <a:off x="3657600" y="2286000"/>
-            <a:ext cx="2468880" cy="914400"/>
+            <a:off x="4892040" y="2468880"/>
+            <a:ext cx="3520440" cy="1005840"/>
           </a:xfrm>
           <a:prstGeom prst="rect">
             <a:avLst/>
@@ -5137,7 +5154,7 @@
               <a:buNone/>
             </a:pPr>
             <a:r>
-              <a:rPr lang="en-US" sz="1100" dirty="0">
+              <a:rPr lang="en-US" sz="1200" dirty="0">
                 <a:solidFill>
                   <a:srgbClr val="1A1A2E"/>
                 </a:solidFill>
@@ -5145,16 +5162,16 @@
                 <a:ea typeface="Calibri" pitchFamily="34" charset="-122"/>
                 <a:cs typeface="Calibri" pitchFamily="34" charset="-120"/>
               </a:rPr>
-              <a:t>2 層 Encoder + 4 head</a:t>
-            </a:r>
-            <a:endParaRPr lang="en-US" sz="1100" dirty="0"/>
-          </a:p>
-          <a:p>
-            <a:pPr indent="0" marL="0">
-              <a:buNone/>
-            </a:pPr>
-            <a:r>
-              <a:rPr lang="en-US" sz="1100" dirty="0">
+              <a:t>2 層 Encoder Block + 4 個 head</a:t>
+            </a:r>
+            <a:endParaRPr lang="en-US" sz="1200" dirty="0"/>
+          </a:p>
+          <a:p>
+            <a:pPr indent="0" marL="0">
+              <a:buNone/>
+            </a:pPr>
+            <a:r>
+              <a:rPr lang="en-US" sz="1200" dirty="0">
                 <a:solidFill>
                   <a:srgbClr val="1A1A2E"/>
                 </a:solidFill>
@@ -5164,7 +5181,24 @@
               </a:rPr>
               <a:t>Sinusoidal Positional Encoding</a:t>
             </a:r>
-            <a:endParaRPr lang="en-US" sz="1100" dirty="0"/>
+            <a:endParaRPr lang="en-US" sz="1200" dirty="0"/>
+          </a:p>
+          <a:p>
+            <a:pPr indent="0" marL="0">
+              <a:buNone/>
+            </a:pPr>
+            <a:r>
+              <a:rPr lang="en-US" sz="1200" dirty="0">
+                <a:solidFill>
+                  <a:srgbClr val="1A1A2E"/>
+                </a:solidFill>
+                <a:latin typeface="Calibri" pitchFamily="34" charset="0"/>
+                <a:ea typeface="Calibri" pitchFamily="34" charset="-122"/>
+                <a:cs typeface="Calibri" pitchFamily="34" charset="-120"/>
+              </a:rPr>
+              <a:t>AdamW + Cosine LR Schedule</a:t>
+            </a:r>
+            <a:endParaRPr lang="en-US" sz="1200" dirty="0"/>
           </a:p>
         </p:txBody>
       </p:sp>
@@ -5176,8 +5210,8 @@
         </p:nvSpPr>
         <p:spPr>
           <a:xfrm>
-            <a:off x="3657600" y="3383280"/>
-            <a:ext cx="2468880" cy="228600"/>
+            <a:off x="4892040" y="3611880"/>
+            <a:ext cx="3520440" cy="274320"/>
           </a:xfrm>
           <a:prstGeom prst="rect">
             <a:avLst/>
@@ -5193,7 +5227,7 @@
               <a:buNone/>
             </a:pPr>
             <a:r>
-              <a:rPr lang="en-US" sz="1100" b="1" dirty="0">
+              <a:rPr lang="en-US" sz="1300" b="1" dirty="0">
                 <a:solidFill>
                   <a:srgbClr val="F96167"/>
                 </a:solidFill>
@@ -5203,7 +5237,7 @@
               </a:rPr>
               <a:t>優勢</a:t>
             </a:r>
-            <a:endParaRPr lang="en-US" sz="1100" dirty="0"/>
+            <a:endParaRPr lang="en-US" sz="1300" dirty="0"/>
           </a:p>
         </p:txBody>
       </p:sp>
@@ -5215,8 +5249,8 @@
         </p:nvSpPr>
         <p:spPr>
           <a:xfrm>
-            <a:off x="3657600" y="3611880"/>
-            <a:ext cx="2468880" cy="1188720"/>
+            <a:off x="4892040" y="3886200"/>
+            <a:ext cx="3520440" cy="1005840"/>
           </a:xfrm>
           <a:prstGeom prst="rect">
             <a:avLst/>
@@ -5235,7 +5269,7 @@
               <a:buNone/>
             </a:pPr>
             <a:r>
-              <a:rPr lang="en-US" sz="1100" dirty="0">
+              <a:rPr lang="en-US" sz="1200" dirty="0">
                 <a:solidFill>
                   <a:srgbClr val="1A1A2E"/>
                 </a:solidFill>
@@ -5243,9 +5277,9 @@
                 <a:ea typeface="Calibri" pitchFamily="34" charset="-122"/>
                 <a:cs typeface="Calibri" pitchFamily="34" charset="-120"/>
               </a:rPr>
-              <a:t>平行計算快</a:t>
-            </a:r>
-            <a:endParaRPr lang="en-US" sz="1100" dirty="0"/>
+              <a:t>平行計算速度快</a:t>
+            </a:r>
+            <a:endParaRPr lang="en-US" sz="1200" dirty="0"/>
           </a:p>
           <a:p>
             <a:pPr indent="0" marL="0">
@@ -5255,7 +5289,7 @@
               <a:buNone/>
             </a:pPr>
             <a:r>
-              <a:rPr lang="en-US" sz="1100" dirty="0">
+              <a:rPr lang="en-US" sz="1200" dirty="0">
                 <a:solidFill>
                   <a:srgbClr val="1A1A2E"/>
                 </a:solidFill>
@@ -5263,9 +5297,9 @@
                 <a:ea typeface="Calibri" pitchFamily="34" charset="-122"/>
                 <a:cs typeface="Calibri" pitchFamily="34" charset="-120"/>
               </a:rPr>
-              <a:t>長期依賴強</a:t>
-            </a:r>
-            <a:endParaRPr lang="en-US" sz="1100" dirty="0"/>
+              <a:t>長期依賴關係處理強</a:t>
+            </a:r>
+            <a:endParaRPr lang="en-US" sz="1200" dirty="0"/>
           </a:p>
           <a:p>
             <a:pPr indent="0" marL="0">
@@ -5275,7 +5309,7 @@
               <a:buNone/>
             </a:pPr>
             <a:r>
-              <a:rPr lang="en-US" sz="1100" dirty="0">
+              <a:rPr lang="en-US" sz="1200" dirty="0">
                 <a:solidFill>
                   <a:srgbClr val="1A1A2E"/>
                 </a:solidFill>
@@ -5283,365 +5317,9 @@
                 <a:ea typeface="Calibri" pitchFamily="34" charset="-122"/>
                 <a:cs typeface="Calibri" pitchFamily="34" charset="-120"/>
               </a:rPr>
-              <a:t>業界主流</a:t>
-            </a:r>
-            <a:endParaRPr lang="en-US" sz="1100" dirty="0"/>
-          </a:p>
-        </p:txBody>
-      </p:sp>
-      <p:sp>
-        <p:nvSpPr>
-          <p:cNvPr id="20" name="Shape 18"/>
-          <p:cNvSpPr/>
-          <p:nvPr/>
-        </p:nvSpPr>
-        <p:spPr>
-          <a:xfrm>
-            <a:off x="6583680" y="1280160"/>
-            <a:ext cx="2697480" cy="3657600"/>
-          </a:xfrm>
-          <a:prstGeom prst="rect">
-            <a:avLst/>
-          </a:prstGeom>
-          <a:solidFill>
-            <a:srgbClr val="F8F9FC"/>
-          </a:solidFill>
-          <a:ln w="12700">
-            <a:solidFill>
-              <a:srgbClr val="0D9488"/>
-            </a:solidFill>
-            <a:prstDash val="solid"/>
-          </a:ln>
-        </p:spPr>
-      </p:sp>
-      <p:sp>
-        <p:nvSpPr>
-          <p:cNvPr id="21" name="Shape 19"/>
-          <p:cNvSpPr/>
-          <p:nvPr/>
-        </p:nvSpPr>
-        <p:spPr>
-          <a:xfrm>
-            <a:off x="6583680" y="1280160"/>
-            <a:ext cx="2697480" cy="640080"/>
-          </a:xfrm>
-          <a:prstGeom prst="rect">
-            <a:avLst/>
-          </a:prstGeom>
-          <a:solidFill>
-            <a:srgbClr val="0D9488"/>
-          </a:solidFill>
-          <a:ln/>
-        </p:spPr>
-      </p:sp>
-      <p:sp>
-        <p:nvSpPr>
-          <p:cNvPr id="22" name="Text 20"/>
-          <p:cNvSpPr/>
-          <p:nvPr/>
-        </p:nvSpPr>
-        <p:spPr>
-          <a:xfrm>
-            <a:off x="6720840" y="1298448"/>
-            <a:ext cx="2468880" cy="411480"/>
-          </a:xfrm>
-          <a:prstGeom prst="rect">
-            <a:avLst/>
-          </a:prstGeom>
-          <a:noFill/>
-          <a:ln/>
-        </p:spPr>
-        <p:txBody>
-          <a:bodyPr wrap="square" lIns="0" tIns="0" rIns="0" bIns="0" rtlCol="0" anchor="ctr"/>
-          <a:lstStyle/>
-          <a:p>
-            <a:pPr indent="0" marL="0">
-              <a:buNone/>
-            </a:pPr>
-            <a:r>
-              <a:rPr lang="en-US" sz="2200" b="1" dirty="0">
-                <a:solidFill>
-                  <a:srgbClr val="FFFFFF"/>
-                </a:solidFill>
-                <a:latin typeface="Calibri" pitchFamily="34" charset="0"/>
-                <a:ea typeface="Calibri" pitchFamily="34" charset="-122"/>
-                <a:cs typeface="Calibri" pitchFamily="34" charset="-120"/>
-              </a:rPr>
-              <a:t>XGBoost</a:t>
-            </a:r>
-            <a:endParaRPr lang="en-US" sz="2200" dirty="0"/>
-          </a:p>
-        </p:txBody>
-      </p:sp>
-      <p:sp>
-        <p:nvSpPr>
-          <p:cNvPr id="23" name="Text 21"/>
-          <p:cNvSpPr/>
-          <p:nvPr/>
-        </p:nvSpPr>
-        <p:spPr>
-          <a:xfrm>
-            <a:off x="6720840" y="1664208"/>
-            <a:ext cx="2468880" cy="228600"/>
-          </a:xfrm>
-          <a:prstGeom prst="rect">
-            <a:avLst/>
-          </a:prstGeom>
-          <a:noFill/>
-          <a:ln/>
-        </p:spPr>
-        <p:txBody>
-          <a:bodyPr wrap="square" lIns="0" tIns="0" rIns="0" bIns="0" rtlCol="0" anchor="ctr"/>
-          <a:lstStyle/>
-          <a:p>
-            <a:pPr indent="0" marL="0">
-              <a:buNone/>
-            </a:pPr>
-            <a:r>
-              <a:rPr lang="en-US" sz="1000" i="1" dirty="0">
-                <a:solidFill>
-                  <a:srgbClr val="FFFFFF"/>
-                </a:solidFill>
-                <a:latin typeface="Calibri" pitchFamily="34" charset="0"/>
-                <a:ea typeface="Calibri" pitchFamily="34" charset="-122"/>
-                <a:cs typeface="Calibri" pitchFamily="34" charset="-120"/>
-              </a:rPr>
-              <a:t>Gradient Boosting Tree</a:t>
-            </a:r>
-            <a:endParaRPr lang="en-US" sz="1000" dirty="0"/>
-          </a:p>
-        </p:txBody>
-      </p:sp>
-      <p:sp>
-        <p:nvSpPr>
-          <p:cNvPr id="24" name="Text 22"/>
-          <p:cNvSpPr/>
-          <p:nvPr/>
-        </p:nvSpPr>
-        <p:spPr>
-          <a:xfrm>
-            <a:off x="6720840" y="2057400"/>
-            <a:ext cx="2468880" cy="228600"/>
-          </a:xfrm>
-          <a:prstGeom prst="rect">
-            <a:avLst/>
-          </a:prstGeom>
-          <a:noFill/>
-          <a:ln/>
-        </p:spPr>
-        <p:txBody>
-          <a:bodyPr wrap="square" lIns="0" tIns="0" rIns="0" bIns="0" rtlCol="0" anchor="ctr"/>
-          <a:lstStyle/>
-          <a:p>
-            <a:pPr indent="0" marL="0">
-              <a:buNone/>
-            </a:pPr>
-            <a:r>
-              <a:rPr lang="en-US" sz="1100" b="1" dirty="0">
-                <a:solidFill>
-                  <a:srgbClr val="0D9488"/>
-                </a:solidFill>
-                <a:latin typeface="Calibri" pitchFamily="34" charset="0"/>
-                <a:ea typeface="Calibri" pitchFamily="34" charset="-122"/>
-                <a:cs typeface="Calibri" pitchFamily="34" charset="-120"/>
-              </a:rPr>
-              <a:t>架構</a:t>
-            </a:r>
-            <a:endParaRPr lang="en-US" sz="1100" dirty="0"/>
-          </a:p>
-        </p:txBody>
-      </p:sp>
-      <p:sp>
-        <p:nvSpPr>
-          <p:cNvPr id="25" name="Text 23"/>
-          <p:cNvSpPr/>
-          <p:nvPr/>
-        </p:nvSpPr>
-        <p:spPr>
-          <a:xfrm>
-            <a:off x="6720840" y="2286000"/>
-            <a:ext cx="2468880" cy="914400"/>
-          </a:xfrm>
-          <a:prstGeom prst="rect">
-            <a:avLst/>
-          </a:prstGeom>
-          <a:noFill/>
-          <a:ln/>
-        </p:spPr>
-        <p:txBody>
-          <a:bodyPr wrap="square" lIns="0" tIns="0" rIns="0" bIns="0" rtlCol="0" anchor="ctr"/>
-          <a:lstStyle/>
-          <a:p>
-            <a:pPr indent="0" marL="0">
-              <a:buNone/>
-            </a:pPr>
-            <a:r>
-              <a:rPr lang="en-US" sz="1100" dirty="0">
-                <a:solidFill>
-                  <a:srgbClr val="1A1A2E"/>
-                </a:solidFill>
-                <a:latin typeface="Calibri" pitchFamily="34" charset="0"/>
-                <a:ea typeface="Calibri" pitchFamily="34" charset="-122"/>
-                <a:cs typeface="Calibri" pitchFamily="34" charset="-120"/>
-              </a:rPr>
-              <a:t>300 棵 boosting tree</a:t>
-            </a:r>
-            <a:endParaRPr lang="en-US" sz="1100" dirty="0"/>
-          </a:p>
-          <a:p>
-            <a:pPr indent="0" marL="0">
-              <a:buNone/>
-            </a:pPr>
-            <a:r>
-              <a:rPr lang="en-US" sz="1100" dirty="0">
-                <a:solidFill>
-                  <a:srgbClr val="1A1A2E"/>
-                </a:solidFill>
-                <a:latin typeface="Calibri" pitchFamily="34" charset="0"/>
-                <a:ea typeface="Calibri" pitchFamily="34" charset="-122"/>
-                <a:cs typeface="Calibri" pitchFamily="34" charset="-120"/>
-              </a:rPr>
-              <a:t>+ early stopping</a:t>
-            </a:r>
-            <a:endParaRPr lang="en-US" sz="1100" dirty="0"/>
-          </a:p>
-          <a:p>
-            <a:pPr indent="0" marL="0">
-              <a:buNone/>
-            </a:pPr>
-            <a:r>
-              <a:rPr lang="en-US" sz="1100" dirty="0">
-                <a:solidFill>
-                  <a:srgbClr val="1A1A2E"/>
-                </a:solidFill>
-                <a:latin typeface="Calibri" pitchFamily="34" charset="0"/>
-                <a:ea typeface="Calibri" pitchFamily="34" charset="-122"/>
-                <a:cs typeface="Calibri" pitchFamily="34" charset="-120"/>
-              </a:rPr>
-              <a:t>時間窗展平為 2D</a:t>
-            </a:r>
-            <a:endParaRPr lang="en-US" sz="1100" dirty="0"/>
-          </a:p>
-        </p:txBody>
-      </p:sp>
-      <p:sp>
-        <p:nvSpPr>
-          <p:cNvPr id="26" name="Text 24"/>
-          <p:cNvSpPr/>
-          <p:nvPr/>
-        </p:nvSpPr>
-        <p:spPr>
-          <a:xfrm>
-            <a:off x="6720840" y="3383280"/>
-            <a:ext cx="2468880" cy="228600"/>
-          </a:xfrm>
-          <a:prstGeom prst="rect">
-            <a:avLst/>
-          </a:prstGeom>
-          <a:noFill/>
-          <a:ln/>
-        </p:spPr>
-        <p:txBody>
-          <a:bodyPr wrap="square" lIns="0" tIns="0" rIns="0" bIns="0" rtlCol="0" anchor="ctr"/>
-          <a:lstStyle/>
-          <a:p>
-            <a:pPr indent="0" marL="0">
-              <a:buNone/>
-            </a:pPr>
-            <a:r>
-              <a:rPr lang="en-US" sz="1100" b="1" dirty="0">
-                <a:solidFill>
-                  <a:srgbClr val="0D9488"/>
-                </a:solidFill>
-                <a:latin typeface="Calibri" pitchFamily="34" charset="0"/>
-                <a:ea typeface="Calibri" pitchFamily="34" charset="-122"/>
-                <a:cs typeface="Calibri" pitchFamily="34" charset="-120"/>
-              </a:rPr>
-              <a:t>優勢</a:t>
-            </a:r>
-            <a:endParaRPr lang="en-US" sz="1100" dirty="0"/>
-          </a:p>
-        </p:txBody>
-      </p:sp>
-      <p:sp>
-        <p:nvSpPr>
-          <p:cNvPr id="27" name="Text 25"/>
-          <p:cNvSpPr/>
-          <p:nvPr/>
-        </p:nvSpPr>
-        <p:spPr>
-          <a:xfrm>
-            <a:off x="6720840" y="3611880"/>
-            <a:ext cx="2468880" cy="1188720"/>
-          </a:xfrm>
-          <a:prstGeom prst="rect">
-            <a:avLst/>
-          </a:prstGeom>
-          <a:noFill/>
-          <a:ln/>
-        </p:spPr>
-        <p:txBody>
-          <a:bodyPr wrap="square" lIns="0" tIns="0" rIns="0" bIns="0" rtlCol="0" anchor="ctr"/>
-          <a:lstStyle/>
-          <a:p>
-            <a:pPr indent="0" marL="0">
-              <a:spcAft>
-                <a:spcPts val="200"/>
-              </a:spcAft>
-              <a:buNone/>
-            </a:pPr>
-            <a:r>
-              <a:rPr lang="en-US" sz="1100" dirty="0">
-                <a:solidFill>
-                  <a:srgbClr val="1A1A2E"/>
-                </a:solidFill>
-                <a:latin typeface="Calibri" pitchFamily="34" charset="0"/>
-                <a:ea typeface="Calibri" pitchFamily="34" charset="-122"/>
-                <a:cs typeface="Calibri" pitchFamily="34" charset="-120"/>
-              </a:rPr>
-              <a:t>快速</a:t>
-            </a:r>
-            <a:endParaRPr lang="en-US" sz="1100" dirty="0"/>
-          </a:p>
-          <a:p>
-            <a:pPr indent="0" marL="0">
-              <a:spcAft>
-                <a:spcPts val="200"/>
-              </a:spcAft>
-              <a:buNone/>
-            </a:pPr>
-            <a:r>
-              <a:rPr lang="en-US" sz="1100" dirty="0">
-                <a:solidFill>
-                  <a:srgbClr val="1A1A2E"/>
-                </a:solidFill>
-                <a:latin typeface="Calibri" pitchFamily="34" charset="0"/>
-                <a:ea typeface="Calibri" pitchFamily="34" charset="-122"/>
-                <a:cs typeface="Calibri" pitchFamily="34" charset="-120"/>
-              </a:rPr>
-              <a:t>強 baseline</a:t>
-            </a:r>
-            <a:endParaRPr lang="en-US" sz="1100" dirty="0"/>
-          </a:p>
-          <a:p>
-            <a:pPr indent="0" marL="0">
-              <a:spcAft>
-                <a:spcPts val="200"/>
-              </a:spcAft>
-              <a:buNone/>
-            </a:pPr>
-            <a:r>
-              <a:rPr lang="en-US" sz="1100" dirty="0">
-                <a:solidFill>
-                  <a:srgbClr val="1A1A2E"/>
-                </a:solidFill>
-                <a:latin typeface="Calibri" pitchFamily="34" charset="0"/>
-                <a:ea typeface="Calibri" pitchFamily="34" charset="-122"/>
-                <a:cs typeface="Calibri" pitchFamily="34" charset="-120"/>
-              </a:rPr>
-              <a:t>可解釋</a:t>
-            </a:r>
-            <a:endParaRPr lang="en-US" sz="1100" dirty="0"/>
+              <a:t>業界主流現代架構</a:t>
+            </a:r>
+            <a:endParaRPr lang="en-US" sz="1200" dirty="0"/>
           </a:p>
         </p:txBody>
       </p:sp>
@@ -7861,7 +7539,7 @@
                 <a:ea typeface="Calibri" pitchFamily="34" charset="-122"/>
                 <a:cs typeface="Calibri" pitchFamily="34" charset="-120"/>
               </a:rPr>
-              <a:t>預期亮點:  </a:t>
+              <a:t>實測結果:  </a:t>
             </a:r>
             <a:pPr indent="0" marL="0">
               <a:buNone/>
@@ -7875,7 +7553,7 @@
                 <a:ea typeface="Calibri" pitchFamily="34" charset="-122"/>
                 <a:cs typeface="Calibri" pitchFamily="34" charset="-120"/>
               </a:rPr>
-              <a:t>Transformer RMSE 最低 (10.87)  ·  AI 策略年化報酬 +38%  ·  最大回撤 -12.4%  ·  Sharpe 1.87</a:t>
+              <a:t>LSTM 方向準確率 60.71%  ·  MA 策略年化報酬 +39.6%  ·  最大回撤 -17.7%  ·  Sharpe 1.55</a:t>
             </a:r>
             <a:endParaRPr lang="en-US" sz="1300" dirty="0"/>
           </a:p>
@@ -8724,7 +8402,7 @@
                 <a:ea typeface="Calibri" pitchFamily="34" charset="-122"/>
                 <a:cs typeface="Calibri" pitchFamily="34" charset="-120"/>
               </a:rPr>
-              <a:t>機器學習: </a:t>
+              <a:t>資料前處理: </a:t>
             </a:r>
             <a:pPr indent="0" marL="0">
               <a:spcAft>
@@ -8741,7 +8419,7 @@
                 <a:ea typeface="Calibri" pitchFamily="34" charset="-122"/>
                 <a:cs typeface="Calibri" pitchFamily="34" charset="-120"/>
               </a:rPr>
-              <a:t>XGBoost, scikit-learn</a:t>
+              <a:t>scikit-learn (MinMax 正規化、時序切分)</a:t>
             </a:r>
             <a:endParaRPr lang="en-US" sz="1300" dirty="0"/>
           </a:p>

</xml_diff>